<commit_message>
Add Optuna tuning and regenerate final deliverables
- optuna_tuning.py: hyperparameter search for the repurchase model
- generate_final_deliverables.py, rebuild_pickle.py, build_pptx.py: build helpers
- refresh notebook, artifacts (metrics + ROC/calibration/deciles/importance plots)
- update lecturer deck and repurchase summary presentation

Co-Authored-By: Claude Opus 4.8 (1M context) <noreply@anthropic.com>
</commit_message>
<xml_diff>
--- a/presentacion_recompra.pptx
+++ b/presentacion_recompra.pptx
@@ -6574,7 +6574,7 @@
         <p:spPr>
           <a:xfrm>
             <a:off x="137160" y="1097280"/>
-            <a:ext cx="2633472" cy="2194560"/>
+            <a:ext cx="2793076" cy="2194560"/>
           </a:xfrm>
           <a:prstGeom prst="rect">
             <a:avLst/>
@@ -6622,7 +6622,7 @@
         <p:spPr>
           <a:xfrm>
             <a:off x="3017520" y="1097280"/>
-            <a:ext cx="3413760" cy="2194560"/>
+            <a:ext cx="2700997" cy="2194560"/>
           </a:xfrm>
           <a:prstGeom prst="rect">
             <a:avLst/>
@@ -6653,31 +6653,31 @@
           <a:p>
             <a:r>
               <a:rPr sz="1300" b="1"/>
-              <a:t>Modelo final: RandomForest</a:t>
+              <a:t>Modelo final: Optuna_xgb_tuned</a:t>
             </a:r>
           </a:p>
           <a:p>
             <a:r>
               <a:rPr sz="1300"/>
-              <a:t>AUC = 0.803   AP = 0.833</a:t>
+              <a:t>Desempeño actual:  AUC = 0.8141   AP = 0.8427</a:t>
             </a:r>
           </a:p>
           <a:p>
             <a:r>
               <a:rPr sz="1300"/>
-              <a:t>Top features: Recency, BuysPerMonth, Monetary, AvgQty</a:t>
+              <a:t>Modelo RF anterior:  AUC = 0.8030   AP = 0.8329</a:t>
             </a:r>
           </a:p>
           <a:p>
             <a:r>
               <a:rPr sz="1300"/>
-              <a:t>Top decil score → 97% recompran</a:t>
+              <a:t>Mejora de performance:  ++0.0111 AUC</a:t>
             </a:r>
           </a:p>
           <a:p>
             <a:r>
               <a:rPr sz="1300"/>
-              <a:t>Bottom decil   → 12% recompran</a:t>
+              <a:t>Top decil score → 97.6% recompran (vs 11.4% decil bajo)</a:t>
             </a:r>
           </a:p>
         </p:txBody>
@@ -6789,7 +6789,7 @@
             </a:pPr>
             <a:r>
               <a:rPr sz="1200"/>
-              <a:t>• Modelo RandomForest con AUC test ≈ 0.80, AP ≈ 0.83.</a:t>
+              <a:t>• Modelo Optuna_xgb_tuned con AUC test ≈ 0.8141, AP ≈ 0.8427.</a:t>
             </a:r>
             <a:endParaRPr sz="1200"/>
           </a:p>
@@ -6802,13 +6802,13 @@
           <a:p>
             <a:r>
               <a:rPr sz="1200"/>
-              <a:t>• Lift fuerte: top 10% del score recompra 97% vs. 12% en el último decil.</a:t>
+              <a:t>• Lift fuerte: top 10% del score recompra 97.6% vs. 11.4% en el último decil.</a:t>
             </a:r>
           </a:p>
           <a:p>
             <a:r>
               <a:rPr sz="1200"/>
-              <a:t>• Variables RFM dominan; la dimensión territorial (IsUK) aporta poco.</a:t>
+              <a:t>• Variables comportamentales e IPI superan a la línea base.</a:t>
             </a:r>
           </a:p>
           <a:p>

</xml_diff>